<commit_message>
docs(lesson2): open with what they built last week, drop the self-intro
Same students, second lesson — a self-introduction is dead air. The opening
page is now last week's deliverable as a four-step flow (spec in ChatGPT →
Codex writes it → GitHub Actions runs it → weekly digest), landing on what
today adds to the same repo: a screen, an AI call, and a public URL.
</commit_message>
<xml_diff>
--- a/slides/2026-08-13-第二堂-做一個自己的AI-Agent.pptx
+++ b/slides/2026-08-13-第二堂-做一個自己的AI-Agent.pptx
@@ -1448,17 +1448,27 @@
           <a:lstStyle/>
           <a:p>
             <a:r>
-              <a:t>四格帶過，不要念履歷。</a:t>
-            </a:r>
-          </a:p>
-          <a:p>
-            <a:r>
-              <a:t>產業那行是重點：他們即將進不同的公司，看到「同一套方法用在八個不同產業」比聽我做過什麼產品有用。</a:t>
-            </a:r>
-          </a:p>
-          <a:p>
-            <a:r>
-              <a:t>要講的只有一句：我不是因為很會寫 code 才做得出 AI 產品，是因為我知道要做什麼。</a:t>
+              <a:t>一分鐘帶過，不要重講第一堂。</a:t>
+            </a:r>
+          </a:p>
+          <a:p>
+            <a:r>
+              <a:t>只要確認三件事他們記得：① 規格是人談的 ② code 是 Codex 寫的 ③ GitHub Actions 幫你定時跑。</a:t>
+            </a:r>
+          </a:p>
+          <a:p>
+            <a:r>
+              <a:t>然後把今天定位成「同一個產品往前長」——第一堂那顆競品監控器沒有畫面、也沒有人能打開它；今天補上這兩件。</a:t>
+            </a:r>
+          </a:p>
+          <a:p>
+            <a:r>
+              <a:t>順便講：第一堂的成果我已經搬進今天這顆 repo，不用在兩邊搬檔案。</a:t>
+            </a:r>
+          </a:p>
+          <a:p>
+            <a:r>
+              <a:t>版面放不下但要口頭補的：換監控對象改 config、換時間改 workflow、換週報格式改主程式 —— 上週真正學到的是「你知道東西住在哪一格」。</a:t>
             </a:r>
           </a:p>
         </p:txBody>
@@ -12907,7 +12917,7 @@
                 <a:latin typeface="Helvetica Neue"/>
                 <a:ea typeface="Noto Sans TC"/>
               </a:rPr>
-              <a:t>蔡子揚 Young</a:t>
+              <a:t>上週你做出來的東西</a:t>
             </a:r>
           </a:p>
         </p:txBody>
@@ -12960,8 +12970,8 @@
         </p:nvSpPr>
         <p:spPr>
           <a:xfrm>
-            <a:off x="914400" y="3191256"/>
-            <a:ext cx="2151811" cy="1627632"/>
+            <a:off x="914400" y="3264408"/>
+            <a:ext cx="2151811" cy="1481328"/>
           </a:xfrm>
           <a:prstGeom prst="roundRect">
             <a:avLst>
@@ -13009,8 +13019,8 @@
                 <a:latin typeface="Helvetica Neue"/>
                 <a:ea typeface="Noto Sans TC"/>
               </a:rPr>
-              <a:t>硬體韌體
-2009-2015</a:t>
+              <a:t>在 ChatGPT
+談清楚規格</a:t>
             </a:r>
           </a:p>
         </p:txBody>
@@ -13067,8 +13077,8 @@
         </p:nvSpPr>
         <p:spPr>
           <a:xfrm>
-            <a:off x="3651427" y="3191256"/>
-            <a:ext cx="2151811" cy="1627632"/>
+            <a:off x="3651427" y="3264408"/>
+            <a:ext cx="2151811" cy="1481328"/>
           </a:xfrm>
           <a:prstGeom prst="roundRect">
             <a:avLst>
@@ -13116,8 +13126,8 @@
                 <a:latin typeface="Helvetica Neue"/>
                 <a:ea typeface="Noto Sans TC"/>
               </a:rPr>
-              <a:t>全端 · 資料
-PM</a:t>
+              <a:t>交給 Codex
+它寫 code</a:t>
             </a:r>
           </a:p>
         </p:txBody>
@@ -13174,8 +13184,8 @@
         </p:nvSpPr>
         <p:spPr>
           <a:xfrm>
-            <a:off x="6388455" y="3191256"/>
-            <a:ext cx="2151811" cy="1627632"/>
+            <a:off x="6388455" y="3264408"/>
+            <a:ext cx="2151811" cy="1481328"/>
           </a:xfrm>
           <a:prstGeom prst="roundRect">
             <a:avLst>
@@ -13223,9 +13233,8 @@
                 <a:latin typeface="Helvetica Neue"/>
                 <a:ea typeface="Noto Sans TC"/>
               </a:rPr>
-              <a:t>產品長
-AI 長
-副執行長</a:t>
+              <a:t>放上 GitHub
+Actions 自動跑</a:t>
             </a:r>
           </a:p>
         </p:txBody>
@@ -13282,8 +13291,8 @@
         </p:nvSpPr>
         <p:spPr>
           <a:xfrm>
-            <a:off x="9125483" y="3191256"/>
-            <a:ext cx="2151811" cy="1627632"/>
+            <a:off x="9125483" y="3264408"/>
+            <a:ext cx="2151811" cy="1481328"/>
           </a:xfrm>
           <a:prstGeom prst="roundRect">
             <a:avLst>
@@ -13331,9 +13340,8 @@
                 <a:latin typeface="Helvetica Neue"/>
                 <a:ea typeface="Noto Sans TC"/>
               </a:rPr>
-              <a:t>AI 產品顧問
-AI 獨立開發者
-AI 創業者</a:t>
+              <a:t>每週自己產
+競品週報</a:t>
             </a:r>
           </a:p>
         </p:txBody>
@@ -13346,8 +13354,8 @@
         </p:nvSpPr>
         <p:spPr>
           <a:xfrm>
-            <a:off x="914400" y="5138928"/>
-            <a:ext cx="10362895" cy="868680"/>
+            <a:off x="914400" y="5230368"/>
+            <a:ext cx="10362895" cy="457200"/>
           </a:xfrm>
           <a:prstGeom prst="rect">
             <a:avLst/>
@@ -13366,15 +13374,54 @@
               </a:lnSpc>
             </a:pPr>
             <a:r>
-              <a:rPr sz="1900" b="0">
+              <a:rPr sz="2000" b="0">
                 <a:solidFill>
                   <a:srgbClr val="4A4A4A"/>
                 </a:solidFill>
                 <a:latin typeface="Helvetica Neue"/>
                 <a:ea typeface="Noto Sans TC"/>
               </a:rPr>
-              <a:t>接過的產業：教育 · 醫療 · 金融 · 製造
-我做的事：把想法變成真的能用的產品 —— 從規格到上線</a:t>
+              <a:t>重點不是「會寫程式」，是你講兩句中文、它自己去做</a:t>
+            </a:r>
+          </a:p>
+        </p:txBody>
+      </p:sp>
+      <p:sp>
+        <p:nvSpPr>
+          <p:cNvPr id="13" name="TextBox 12"/>
+          <p:cNvSpPr txBox="1"/>
+          <p:nvPr/>
+        </p:nvSpPr>
+        <p:spPr>
+          <a:xfrm>
+            <a:off x="914400" y="5907024"/>
+            <a:ext cx="10362895" cy="457200"/>
+          </a:xfrm>
+          <a:prstGeom prst="rect">
+            <a:avLst/>
+          </a:prstGeom>
+          <a:noFill/>
+        </p:spPr>
+        <p:txBody>
+          <a:bodyPr wrap="square" lIns="0" rIns="0" tIns="0" bIns="0" anchor="t">
+            <a:spAutoFit/>
+          </a:bodyPr>
+          <a:lstStyle/>
+          <a:p>
+            <a:pPr algn="l">
+              <a:lnSpc>
+                <a:spcPct val="128000"/>
+              </a:lnSpc>
+            </a:pPr>
+            <a:r>
+              <a:rPr sz="2000" b="1">
+                <a:solidFill>
+                  <a:srgbClr val="C2410C"/>
+                </a:solidFill>
+                <a:latin typeface="Helvetica Neue"/>
+                <a:ea typeface="Noto Sans TC"/>
+              </a:rPr>
+              <a:t>今天在同一顆 repo 上往前接：讓它有畫面、有 AI、而且活在網路上</a:t>
             </a:r>
           </a:p>
         </p:txBody>

</xml_diff>

<commit_message>
docs(lesson2): refresh slides after the key-handling and quota corrections
</commit_message>
<xml_diff>
--- a/slides/2026-08-13-第二堂-做一個自己的AI-Agent.pptx
+++ b/slides/2026-08-13-第二堂-做一個自己的AI-Agent.pptx
@@ -9382,7 +9382,7 @@
                 <a:latin typeface="Menlo"/>
                 <a:ea typeface="Noto Sans TC"/>
               </a:rPr>
-              <a:t>2. 部署到 Vercel production，第一次問的設定全部用預設</a:t>
+              <a:t>2. 部署到 Vercel production；問到專案根目錄要選哪個，選 starter-kit，其餘用預設</a:t>
             </a:r>
           </a:p>
           <a:p>
@@ -9399,7 +9399,7 @@
                 <a:latin typeface="Menlo"/>
                 <a:ea typeface="Noto Sans TC"/>
               </a:rPr>
-              <a:t>3. 把 GROQ_API_KEY 加進環境變數（key 我貼給你，不要印在畫面上）</a:t>
+              <a:t>3. 要加 GROQ_API_KEY 的時候停下來告訴我，我自己去 Vercel 貼</a:t>
             </a:r>
           </a:p>
           <a:p>
@@ -9416,7 +9416,24 @@
                 <a:latin typeface="Menlo"/>
                 <a:ea typeface="Noto Sans TC"/>
               </a:rPr>
-              <a:t>4. 加完再部署一次讓 key 生效，不重跑不會生效</a:t>
+              <a:t>   不要問我 key、不要把它寫進任何檔案或印出來</a:t>
+            </a:r>
+          </a:p>
+          <a:p>
+            <a:pPr algn="l">
+              <a:lnSpc>
+                <a:spcPct val="118000"/>
+              </a:lnSpc>
+            </a:pPr>
+            <a:r>
+              <a:rPr sz="1500">
+                <a:solidFill>
+                  <a:srgbClr val="1A1A1A"/>
+                </a:solidFill>
+                <a:latin typeface="Menlo"/>
+                <a:ea typeface="Noto Sans TC"/>
+              </a:rPr>
+              <a:t>4. 我說加好了，你再部署一次 production 讓它生效</a:t>
             </a:r>
           </a:p>
           <a:p>
@@ -9517,7 +9534,7 @@
                 <a:latin typeface="Helvetica Neue"/>
                 <a:ea typeface="Noto Sans TC"/>
               </a:rPr>
-              <a:t>最貴的兩個坑寫在第 1 步跟第 4 步 —— 你不用記，但看到 404 就知道它跳過了</a:t>
+              <a:t>key 由你自己貼進 Vercel，不經過對話 —— 這是今天唯一一件不能外包的事</a:t>
             </a:r>
           </a:p>
         </p:txBody>
@@ -10367,8 +10384,8 @@
                 <a:latin typeface="Helvetica Neue"/>
                 <a:ea typeface="Noto Sans TC"/>
               </a:rPr>
-              <a:t>⚠️ 免費方案的 Codex 一天約 10 次（一次＝它完整跑一輪）
-有 ChatGPT Plus 會順很多；額度用光看 QUICKSTART 的 Plan B</a:t>
+              <a:t>⚠️ Codex 額度依方案、模型、任務大小而變 —— 一次交辦一件小事最省
+快用完時改用較小的模型，或看 usage dashboard；用光看 QUICKSTART 的 Plan B</a:t>
             </a:r>
           </a:p>
         </p:txBody>
@@ -11594,8 +11611,8 @@
               </a:rPr>
               <a:t>他按送出 → ③ 拿你的 key
 去問 ④，要留紀錄才寫 ⑤
-他的瀏覽器永遠碰不到 ④⑤，
-也碰不到你的 key</a:t>
+今天這版，他的瀏覽器只打 ③
+未來前端若直接接 ⑤，就得靠 RLS 擋</a:t>
             </a:r>
           </a:p>
         </p:txBody>
@@ -16215,7 +16232,7 @@
                 <a:latin typeface="Helvetica Neue"/>
                 <a:ea typeface="Noto Sans TC"/>
               </a:rPr>
-              <a:t>✓「退回上一個能動的版本」→ 它自己會做</a:t>
+              <a:t>✓「先找出上一個能動的版本，說明要退哪些檔，等我確認」</a:t>
             </a:r>
           </a:p>
         </p:txBody>
@@ -17278,8 +17295,8 @@
                 <a:latin typeface="Helvetica Neue"/>
                 <a:ea typeface="Noto Sans TC"/>
               </a:rPr>
-              <a:t>🔴 RLS 預設是關的 —— 沒開等於任何人拿你的網址就能讀走整張表、也能清空它
-Supabase 的 anon key 本來就在前端，所以擋人的那層是 RLS，不是那把 key</a:t>
+              <a:t>🔴 anon key 本來就會出現在前端，它不是秘密 —— 真正的邊界是 RLS ＋ 最小權限 policy
+建表後先開 RLS；在你寫出明確 policy 之前，前端不該讀得到任何資料</a:t>
             </a:r>
           </a:p>
         </p:txBody>
@@ -17429,7 +17446,7 @@
                 <a:latin typeface="Helvetica Neue"/>
                 <a:ea typeface="Noto Sans TC"/>
               </a:rPr>
-              <a:t>AI 工程的五層演進 —— 你今天走過前三層</a:t>
+              <a:t>我用來教學的五層地圖（不是官方標準名詞）—— 你今天走過前三層</a:t>
             </a:r>
           </a:p>
         </p:txBody>

</xml_diff>

<commit_message>
docs(lesson2): the key goes in a backend the student opens — Vercel env or GitHub Secrets
</commit_message>
<xml_diff>
--- a/slides/2026-08-13-第二堂-做一個自己的AI-Agent.pptx
+++ b/slides/2026-08-13-第二堂-做一個自己的AI-Agent.pptx
@@ -9507,8 +9507,8 @@
         </p:nvSpPr>
         <p:spPr>
           <a:xfrm>
-            <a:off x="914400" y="5925312"/>
-            <a:ext cx="10362895" cy="411480"/>
+            <a:off x="914400" y="5742432"/>
+            <a:ext cx="10362895" cy="603504"/>
           </a:xfrm>
           <a:prstGeom prst="rect">
             <a:avLst/>
@@ -9527,14 +9527,15 @@
               </a:lnSpc>
             </a:pPr>
             <a:r>
-              <a:rPr sz="1900" b="0">
+              <a:rPr sz="1800" b="0">
                 <a:solidFill>
                   <a:srgbClr val="8A8A85"/>
                 </a:solidFill>
                 <a:latin typeface="Helvetica Neue"/>
                 <a:ea typeface="Noto Sans TC"/>
               </a:rPr>
-              <a:t>key 由你自己貼進 Vercel，不經過對話 —— 這是今天唯一一件不能外包的事</a:t>
+              <a:t>key 你自己到後台貼，不經過 AI 對話 —— 這是今天唯一不能外包的事
+網站 → Vercel 專案 Settings → Environment Variables　｜　排程 → GitHub repo Settings → Secrets and variables → Actions</a:t>
             </a:r>
           </a:p>
         </p:txBody>

</xml_diff>

<commit_message>
docs(lesson2): refresh slides (Groq/RLS wording, git flow, install step)
</commit_message>
<xml_diff>
--- a/slides/2026-08-13-第二堂-做一個自己的AI-Agent.pptx
+++ b/slides/2026-08-13-第二堂-做一個自己的AI-Agent.pptx
@@ -8683,8 +8683,7 @@
                 <a:ea typeface="Noto Sans TC"/>
               </a:rPr>
               <a:t>Codex
-改 code
-開 PR</a:t>
+改 code</a:t>
             </a:r>
           </a:p>
         </p:txBody>
@@ -8790,9 +8789,8 @@
                 <a:latin typeface="Helvetica Neue"/>
                 <a:ea typeface="Noto Sans TC"/>
               </a:rPr>
-              <a:t>GitHub
-你 merge
-CI 檢查</a:t>
+              <a:t>你看 diff
+沒問題才收</a:t>
             </a:r>
           </a:p>
         </p:txBody>
@@ -9046,8 +9044,9 @@
                 <a:latin typeface="Helvetica Neue"/>
                 <a:ea typeface="Noto Sans TC"/>
               </a:rPr>
-              <a:t>你只做兩個動作：把 SPEC 給 Codex、按 merge
-剩下每一步都是自動發生的 —— 這叫 CI/CD</a:t>
+              <a:t>你只做兩個動作：把 SPEC 給 Codex、看過 diff 說 OK
+push 之後每一步都是自動發生的 —— 這叫 CI/CD
+（正式團隊還會加一層 PR review，今天走最短路先讓它活著）</a:t>
             </a:r>
           </a:p>
         </p:txBody>
@@ -15087,7 +15086,7 @@
                 <a:latin typeface="Menlo"/>
                 <a:ea typeface="Noto Sans TC"/>
               </a:rPr>
-              <a:t>「把 temperature 設成 0.2，max_tokens 設成 1200」</a:t>
+              <a:t>「把 temperature 設成 0.2，max_completion_tokens 設成 1200」</a:t>
             </a:r>
           </a:p>
           <a:p>
@@ -15138,7 +15137,7 @@
                 <a:latin typeface="Menlo"/>
                 <a:ea typeface="Noto Sans TC"/>
               </a:rPr>
-              <a:t>max_tokens   輸出上限，避免它寫成一篇論文</a:t>
+              <a:t>max_completion_tokens  輸出上限，避免它寫成一篇論文</a:t>
             </a:r>
           </a:p>
           <a:p>
@@ -15367,7 +15366,7 @@
                 <a:latin typeface="Helvetica Neue"/>
                 <a:ea typeface="Noto Sans TC"/>
               </a:rPr>
-              <a:t>答案被截斷 → 叫它把 max_tokens 加大</a:t>
+              <a:t>答案被截斷 → 叫它把 max_completion_tokens 加大</a:t>
             </a:r>
           </a:p>
         </p:txBody>
@@ -17815,7 +17814,7 @@
                 <a:latin typeface="Helvetica Neue"/>
                 <a:ea typeface="Noto Sans TC"/>
               </a:rPr>
-              <a:t>你 review 過的 SPEC.md ← 就是這層</a:t>
+              <a:t>你 review 過的 SPEC.md 就是一個例子</a:t>
             </a:r>
           </a:p>
         </p:txBody>
@@ -17979,7 +17978,7 @@
                 <a:latin typeface="Helvetica Neue"/>
                 <a:ea typeface="Noto Sans TC"/>
               </a:rPr>
-              <a:t>那個綠勾勾 CI ← 也是這層</a:t>
+              <a:t>CI、權限、工具限制都算，綠勾勾是一種</a:t>
             </a:r>
           </a:p>
         </p:txBody>

</xml_diff>